<commit_message>
Update RISCV-MCU presentation with revised content
</commit_message>
<xml_diff>
--- a/Intro_PPT/RISCV-MCU.pptx
+++ b/Intro_PPT/RISCV-MCU.pptx
@@ -5,10 +5,10 @@
     <p:sldMasterId id="2147483660" r:id="rId1"/>
   </p:sldMasterIdLst>
   <p:notesMasterIdLst>
-    <p:notesMasterId r:id="rId36"/>
+    <p:notesMasterId r:id="rId37"/>
   </p:notesMasterIdLst>
   <p:handoutMasterIdLst>
-    <p:handoutMasterId r:id="rId37"/>
+    <p:handoutMasterId r:id="rId38"/>
   </p:handoutMasterIdLst>
   <p:sldIdLst>
     <p:sldId id="353" r:id="rId2"/>
@@ -25,26 +25,27 @@
     <p:sldId id="305" r:id="rId13"/>
     <p:sldId id="383" r:id="rId14"/>
     <p:sldId id="381" r:id="rId15"/>
-    <p:sldId id="271" r:id="rId16"/>
-    <p:sldId id="377" r:id="rId17"/>
-    <p:sldId id="378" r:id="rId18"/>
-    <p:sldId id="376" r:id="rId19"/>
-    <p:sldId id="362" r:id="rId20"/>
-    <p:sldId id="363" r:id="rId21"/>
-    <p:sldId id="302" r:id="rId22"/>
-    <p:sldId id="364" r:id="rId23"/>
-    <p:sldId id="263" r:id="rId24"/>
-    <p:sldId id="365" r:id="rId25"/>
-    <p:sldId id="272" r:id="rId26"/>
-    <p:sldId id="289" r:id="rId27"/>
-    <p:sldId id="366" r:id="rId28"/>
-    <p:sldId id="367" r:id="rId29"/>
-    <p:sldId id="368" r:id="rId30"/>
-    <p:sldId id="369" r:id="rId31"/>
-    <p:sldId id="370" r:id="rId32"/>
-    <p:sldId id="264" r:id="rId33"/>
-    <p:sldId id="382" r:id="rId34"/>
-    <p:sldId id="374" r:id="rId35"/>
+    <p:sldId id="386" r:id="rId16"/>
+    <p:sldId id="271" r:id="rId17"/>
+    <p:sldId id="377" r:id="rId18"/>
+    <p:sldId id="378" r:id="rId19"/>
+    <p:sldId id="376" r:id="rId20"/>
+    <p:sldId id="362" r:id="rId21"/>
+    <p:sldId id="363" r:id="rId22"/>
+    <p:sldId id="302" r:id="rId23"/>
+    <p:sldId id="364" r:id="rId24"/>
+    <p:sldId id="263" r:id="rId25"/>
+    <p:sldId id="365" r:id="rId26"/>
+    <p:sldId id="272" r:id="rId27"/>
+    <p:sldId id="289" r:id="rId28"/>
+    <p:sldId id="366" r:id="rId29"/>
+    <p:sldId id="367" r:id="rId30"/>
+    <p:sldId id="368" r:id="rId31"/>
+    <p:sldId id="369" r:id="rId32"/>
+    <p:sldId id="370" r:id="rId33"/>
+    <p:sldId id="264" r:id="rId34"/>
+    <p:sldId id="382" r:id="rId35"/>
+    <p:sldId id="374" r:id="rId36"/>
   </p:sldIdLst>
   <p:sldSz cx="12192000" cy="6858000"/>
   <p:notesSz cx="6797675" cy="9926638"/>
@@ -8565,6 +8566,145 @@
   <p:cSld>
     <p:spTree>
       <p:nvGrpSpPr>
+        <p:cNvPr id="1" name=""/>
+        <p:cNvGrpSpPr/>
+        <p:nvPr/>
+      </p:nvGrpSpPr>
+      <p:grpSpPr>
+        <a:xfrm>
+          <a:off x="0" y="0"/>
+          <a:ext cx="0" cy="0"/>
+          <a:chOff x="0" y="0"/>
+          <a:chExt cx="0" cy="0"/>
+        </a:xfrm>
+      </p:grpSpPr>
+      <p:sp>
+        <p:nvSpPr>
+          <p:cNvPr id="2" name="標題 1">
+            <a:extLst>
+              <a:ext uri="{FF2B5EF4-FFF2-40B4-BE49-F238E27FC236}">
+                <a16:creationId xmlns:a16="http://schemas.microsoft.com/office/drawing/2014/main" id="{B91DF792-146A-3A22-E807-445C6BA171D7}"/>
+              </a:ext>
+            </a:extLst>
+          </p:cNvPr>
+          <p:cNvSpPr>
+            <a:spLocks noGrp="1"/>
+          </p:cNvSpPr>
+          <p:nvPr>
+            <p:ph type="title"/>
+          </p:nvPr>
+        </p:nvSpPr>
+        <p:spPr/>
+        <p:txBody>
+          <a:bodyPr/>
+          <a:lstStyle/>
+          <a:p>
+            <a:r>
+              <a:rPr lang="en-US" spc="-1" dirty="0">
+                <a:ea typeface="Calibri"/>
+              </a:rPr>
+              <a:t>MDM (</a:t>
+            </a:r>
+            <a:r>
+              <a:rPr lang="en-US" spc="-1" dirty="0" err="1">
+                <a:ea typeface="Calibri"/>
+              </a:rPr>
+              <a:t>MicroBlaze</a:t>
+            </a:r>
+            <a:r>
+              <a:rPr lang="en-US" spc="-1" dirty="0">
+                <a:ea typeface="Calibri"/>
+              </a:rPr>
+              <a:t> Debug Module)</a:t>
+            </a:r>
+            <a:endParaRPr lang="en-US" dirty="0"/>
+          </a:p>
+        </p:txBody>
+      </p:sp>
+      <p:sp>
+        <p:nvSpPr>
+          <p:cNvPr id="4" name="投影片編號版面配置區 3">
+            <a:extLst>
+              <a:ext uri="{FF2B5EF4-FFF2-40B4-BE49-F238E27FC236}">
+                <a16:creationId xmlns:a16="http://schemas.microsoft.com/office/drawing/2014/main" id="{51BF99A6-FB33-B0D5-25B2-608C67FA4BF1}"/>
+              </a:ext>
+            </a:extLst>
+          </p:cNvPr>
+          <p:cNvSpPr>
+            <a:spLocks noGrp="1"/>
+          </p:cNvSpPr>
+          <p:nvPr>
+            <p:ph type="sldNum" sz="quarter" idx="12"/>
+          </p:nvPr>
+        </p:nvSpPr>
+        <p:spPr/>
+        <p:txBody>
+          <a:bodyPr/>
+          <a:lstStyle/>
+          <a:p>
+            <a:fld id="{F9F9ED32-46C6-469E-9D81-E8934DBD0961}" type="slidenum">
+              <a:rPr lang="zh-TW" altLang="en-US" smtClean="0"/>
+              <a:pPr/>
+              <a:t>15</a:t>
+            </a:fld>
+            <a:endParaRPr lang="zh-TW" altLang="en-US" dirty="0"/>
+          </a:p>
+        </p:txBody>
+      </p:sp>
+      <p:pic>
+        <p:nvPicPr>
+          <p:cNvPr id="8" name="圖片 7">
+            <a:extLst>
+              <a:ext uri="{FF2B5EF4-FFF2-40B4-BE49-F238E27FC236}">
+                <a16:creationId xmlns:a16="http://schemas.microsoft.com/office/drawing/2014/main" id="{84EDD8A3-ED4D-A37C-CC35-46FBC1F2FCF8}"/>
+              </a:ext>
+            </a:extLst>
+          </p:cNvPr>
+          <p:cNvPicPr>
+            <a:picLocks noChangeAspect="1"/>
+          </p:cNvPicPr>
+          <p:nvPr/>
+        </p:nvPicPr>
+        <p:blipFill>
+          <a:blip r:embed="rId2">
+            <a:extLst>
+              <a:ext uri="{28A0092B-C50C-407E-A947-70E740481C1C}">
+                <a14:useLocalDpi xmlns:a14="http://schemas.microsoft.com/office/drawing/2010/main" val="0"/>
+              </a:ext>
+            </a:extLst>
+          </a:blip>
+          <a:stretch>
+            <a:fillRect/>
+          </a:stretch>
+        </p:blipFill>
+        <p:spPr>
+          <a:xfrm>
+            <a:off x="29811" y="0"/>
+            <a:ext cx="12132378" cy="6858000"/>
+          </a:xfrm>
+          <a:prstGeom prst="rect">
+            <a:avLst/>
+          </a:prstGeom>
+        </p:spPr>
+      </p:pic>
+    </p:spTree>
+    <p:extLst>
+      <p:ext uri="{BB962C8B-B14F-4D97-AF65-F5344CB8AC3E}">
+        <p14:creationId xmlns:p14="http://schemas.microsoft.com/office/powerpoint/2010/main" val="3320091747"/>
+      </p:ext>
+    </p:extLst>
+  </p:cSld>
+  <p:clrMapOvr>
+    <a:masterClrMapping/>
+  </p:clrMapOvr>
+</p:sld>
+</file>
+
+<file path=ppt/slides/slide16.xml><?xml version="1.0" encoding="utf-8"?>
+<p:sld xmlns:a="http://schemas.openxmlformats.org/drawingml/2006/main" xmlns:r="http://schemas.openxmlformats.org/officeDocument/2006/relationships" xmlns:p="http://schemas.openxmlformats.org/presentationml/2006/main">
+  <p:cSld>
+    <p:spTree>
+      <p:nvGrpSpPr>
         <p:cNvPr id="1" name="">
           <a:extLst>
             <a:ext uri="{FF2B5EF4-FFF2-40B4-BE49-F238E27FC236}">
@@ -9551,7 +9691,7 @@
               <a:rPr lang="en-TW" smtClean="0">
                 <a:latin typeface="+mn-lt"/>
               </a:rPr>
-              <a:t>15</a:t>
+              <a:t>16</a:t>
             </a:fld>
             <a:endParaRPr lang="en-TW">
               <a:latin typeface="+mn-lt"/>
@@ -9572,7 +9712,7 @@
 </p:sld>
 </file>
 
-<file path=ppt/slides/slide16.xml><?xml version="1.0" encoding="utf-8"?>
+<file path=ppt/slides/slide17.xml><?xml version="1.0" encoding="utf-8"?>
 <p:sld xmlns:a="http://schemas.openxmlformats.org/drawingml/2006/main" xmlns:r="http://schemas.openxmlformats.org/officeDocument/2006/relationships" xmlns:p="http://schemas.openxmlformats.org/presentationml/2006/main">
   <p:cSld>
     <p:spTree>
@@ -9649,7 +9789,7 @@
           <a:p>
             <a:fld id="{F9F9ED32-46C6-469E-9D81-E8934DBD0961}" type="slidenum">
               <a:rPr lang="zh-TW" altLang="en-US" smtClean="0"/>
-              <a:t>16</a:t>
+              <a:t>17</a:t>
             </a:fld>
             <a:endParaRPr lang="zh-TW" altLang="en-US" dirty="0"/>
           </a:p>
@@ -11090,7 +11230,7 @@
 </p:sld>
 </file>
 
-<file path=ppt/slides/slide17.xml><?xml version="1.0" encoding="utf-8"?>
+<file path=ppt/slides/slide18.xml><?xml version="1.0" encoding="utf-8"?>
 <p:sld xmlns:a="http://schemas.openxmlformats.org/drawingml/2006/main" xmlns:r="http://schemas.openxmlformats.org/officeDocument/2006/relationships" xmlns:p="http://schemas.openxmlformats.org/presentationml/2006/main">
   <p:cSld>
     <p:spTree>
@@ -11167,7 +11307,7 @@
           <a:p>
             <a:fld id="{F9F9ED32-46C6-469E-9D81-E8934DBD0961}" type="slidenum">
               <a:rPr lang="zh-TW" altLang="en-US" smtClean="0"/>
-              <a:t>17</a:t>
+              <a:t>18</a:t>
             </a:fld>
             <a:endParaRPr lang="zh-TW" altLang="en-US" dirty="0"/>
           </a:p>
@@ -11836,7 +11976,7 @@
 </p:sld>
 </file>
 
-<file path=ppt/slides/slide18.xml><?xml version="1.0" encoding="utf-8"?>
+<file path=ppt/slides/slide19.xml><?xml version="1.0" encoding="utf-8"?>
 <p:sld xmlns:a="http://schemas.openxmlformats.org/drawingml/2006/main" xmlns:r="http://schemas.openxmlformats.org/officeDocument/2006/relationships" xmlns:p="http://schemas.openxmlformats.org/presentationml/2006/main">
   <p:cSld>
     <p:spTree>
@@ -12056,7 +12196,7 @@
           <a:p>
             <a:fld id="{F9F9ED32-46C6-469E-9D81-E8934DBD0961}" type="slidenum">
               <a:rPr lang="zh-TW" altLang="en-US" smtClean="0"/>
-              <a:t>18</a:t>
+              <a:t>19</a:t>
             </a:fld>
             <a:endParaRPr lang="zh-TW" altLang="en-US" dirty="0"/>
           </a:p>
@@ -12178,7 +12318,289 @@
 </p:sld>
 </file>
 
-<file path=ppt/slides/slide19.xml><?xml version="1.0" encoding="utf-8"?>
+<file path=ppt/slides/slide2.xml><?xml version="1.0" encoding="utf-8"?>
+<p:sld xmlns:a="http://schemas.openxmlformats.org/drawingml/2006/main" xmlns:r="http://schemas.openxmlformats.org/officeDocument/2006/relationships" xmlns:p="http://schemas.openxmlformats.org/presentationml/2006/main">
+  <p:cSld>
+    <p:spTree>
+      <p:nvGrpSpPr>
+        <p:cNvPr id="1" name="">
+          <a:extLst>
+            <a:ext uri="{FF2B5EF4-FFF2-40B4-BE49-F238E27FC236}">
+              <a16:creationId xmlns:a16="http://schemas.microsoft.com/office/drawing/2014/main" id="{B69280E7-411B-5B87-EFAC-03C9325D8EB4}"/>
+            </a:ext>
+          </a:extLst>
+        </p:cNvPr>
+        <p:cNvGrpSpPr/>
+        <p:nvPr/>
+      </p:nvGrpSpPr>
+      <p:grpSpPr>
+        <a:xfrm>
+          <a:off x="0" y="0"/>
+          <a:ext cx="0" cy="0"/>
+          <a:chOff x="0" y="0"/>
+          <a:chExt cx="0" cy="0"/>
+        </a:xfrm>
+      </p:grpSpPr>
+      <p:sp>
+        <p:nvSpPr>
+          <p:cNvPr id="2" name="標題 1">
+            <a:extLst>
+              <a:ext uri="{FF2B5EF4-FFF2-40B4-BE49-F238E27FC236}">
+                <a16:creationId xmlns:a16="http://schemas.microsoft.com/office/drawing/2014/main" id="{4743D012-99B4-A6AC-0CD2-999158835AC4}"/>
+              </a:ext>
+            </a:extLst>
+          </p:cNvPr>
+          <p:cNvSpPr>
+            <a:spLocks noGrp="1"/>
+          </p:cNvSpPr>
+          <p:nvPr>
+            <p:ph type="title"/>
+          </p:nvPr>
+        </p:nvSpPr>
+        <p:spPr/>
+        <p:txBody>
+          <a:bodyPr/>
+          <a:lstStyle/>
+          <a:p>
+            <a:r>
+              <a:rPr lang="en-US" altLang="zh-TW" dirty="0"/>
+              <a:t>Outline</a:t>
+            </a:r>
+            <a:endParaRPr lang="zh-TW" altLang="en-US" dirty="0"/>
+          </a:p>
+        </p:txBody>
+      </p:sp>
+      <p:sp>
+        <p:nvSpPr>
+          <p:cNvPr id="3" name="內容版面配置區 2">
+            <a:extLst>
+              <a:ext uri="{FF2B5EF4-FFF2-40B4-BE49-F238E27FC236}">
+                <a16:creationId xmlns:a16="http://schemas.microsoft.com/office/drawing/2014/main" id="{130A0642-98CF-9CEF-6C6D-052CB538B24A}"/>
+              </a:ext>
+            </a:extLst>
+          </p:cNvPr>
+          <p:cNvSpPr>
+            <a:spLocks noGrp="1"/>
+          </p:cNvSpPr>
+          <p:nvPr>
+            <p:ph idx="1"/>
+          </p:nvPr>
+        </p:nvSpPr>
+        <p:spPr/>
+        <p:txBody>
+          <a:bodyPr/>
+          <a:lstStyle/>
+          <a:p>
+            <a:pPr>
+              <a:spcBef>
+                <a:spcPts val="1200"/>
+              </a:spcBef>
+            </a:pPr>
+            <a:r>
+              <a:rPr lang="en-US" sz="2400" dirty="0">
+                <a:latin typeface="Times New Roman" panose="02020603050405020304" pitchFamily="18" charset="0"/>
+                <a:cs typeface="Times New Roman" panose="02020603050405020304" pitchFamily="18" charset="0"/>
+              </a:rPr>
+              <a:t>FPGA Selection and Spec</a:t>
+            </a:r>
+          </a:p>
+          <a:p>
+            <a:pPr>
+              <a:spcBef>
+                <a:spcPts val="1200"/>
+              </a:spcBef>
+            </a:pPr>
+            <a:r>
+              <a:rPr lang="en-US" sz="2400" dirty="0">
+                <a:latin typeface="Times New Roman" panose="02020603050405020304" pitchFamily="18" charset="0"/>
+                <a:cs typeface="Times New Roman" panose="02020603050405020304" pitchFamily="18" charset="0"/>
+              </a:rPr>
+              <a:t>Microcontroller Overview</a:t>
+            </a:r>
+          </a:p>
+          <a:p>
+            <a:pPr>
+              <a:spcBef>
+                <a:spcPts val="1200"/>
+              </a:spcBef>
+            </a:pPr>
+            <a:r>
+              <a:rPr lang="en-US" altLang="zh-TW" sz="2400" dirty="0">
+                <a:latin typeface="Times New Roman" panose="02020603050405020304" pitchFamily="18" charset="0"/>
+                <a:cs typeface="Times New Roman" panose="02020603050405020304" pitchFamily="18" charset="0"/>
+              </a:rPr>
+              <a:t>Data Path / Instruction Path</a:t>
+            </a:r>
+            <a:endParaRPr lang="en-US" sz="2400" dirty="0">
+              <a:latin typeface="Times New Roman" panose="02020603050405020304" pitchFamily="18" charset="0"/>
+              <a:cs typeface="Times New Roman" panose="02020603050405020304" pitchFamily="18" charset="0"/>
+            </a:endParaRPr>
+          </a:p>
+          <a:p>
+            <a:pPr>
+              <a:spcBef>
+                <a:spcPts val="1200"/>
+              </a:spcBef>
+            </a:pPr>
+            <a:r>
+              <a:rPr lang="en-US" sz="2400" dirty="0">
+                <a:latin typeface="Times New Roman" panose="02020603050405020304" pitchFamily="18" charset="0"/>
+                <a:cs typeface="Times New Roman" panose="02020603050405020304" pitchFamily="18" charset="0"/>
+              </a:rPr>
+              <a:t>MDM / GPIO / Interrupt System / </a:t>
+            </a:r>
+            <a:r>
+              <a:rPr lang="zh-TW" altLang="en-US" sz="2400" dirty="0">
+                <a:latin typeface="Times New Roman" panose="02020603050405020304" pitchFamily="18" charset="0"/>
+                <a:cs typeface="Times New Roman" panose="02020603050405020304" pitchFamily="18" charset="0"/>
+              </a:rPr>
+              <a:t> </a:t>
+            </a:r>
+            <a:r>
+              <a:rPr lang="en-US" altLang="zh-TW" sz="2400" dirty="0">
+                <a:latin typeface="Times New Roman" panose="02020603050405020304" pitchFamily="18" charset="0"/>
+                <a:cs typeface="Times New Roman" panose="02020603050405020304" pitchFamily="18" charset="0"/>
+              </a:rPr>
+              <a:t>Timer &amp; PWM / XADC / UART</a:t>
+            </a:r>
+          </a:p>
+          <a:p>
+            <a:pPr>
+              <a:spcBef>
+                <a:spcPts val="1200"/>
+              </a:spcBef>
+            </a:pPr>
+            <a:r>
+              <a:rPr lang="en-US" altLang="zh-TW" sz="2400" dirty="0">
+                <a:solidFill>
+                  <a:srgbClr val="FF0000"/>
+                </a:solidFill>
+                <a:latin typeface="Times New Roman" panose="02020603050405020304" pitchFamily="18" charset="0"/>
+                <a:cs typeface="Times New Roman" panose="02020603050405020304" pitchFamily="18" charset="0"/>
+              </a:rPr>
+              <a:t>Memory Hierarchy</a:t>
+            </a:r>
+          </a:p>
+          <a:p>
+            <a:pPr>
+              <a:spcBef>
+                <a:spcPts val="1200"/>
+              </a:spcBef>
+            </a:pPr>
+            <a:r>
+              <a:rPr lang="en-US" altLang="zh-TW" sz="2400" dirty="0">
+                <a:latin typeface="Times New Roman" panose="02020603050405020304" pitchFamily="18" charset="0"/>
+                <a:cs typeface="Times New Roman" panose="02020603050405020304" pitchFamily="18" charset="0"/>
+              </a:rPr>
+              <a:t>Hardware Report</a:t>
+            </a:r>
+            <a:endParaRPr lang="en-US" sz="2400" dirty="0">
+              <a:latin typeface="Times New Roman" panose="02020603050405020304" pitchFamily="18" charset="0"/>
+              <a:cs typeface="Times New Roman" panose="02020603050405020304" pitchFamily="18" charset="0"/>
+            </a:endParaRPr>
+          </a:p>
+          <a:p>
+            <a:pPr>
+              <a:spcBef>
+                <a:spcPts val="1200"/>
+              </a:spcBef>
+            </a:pPr>
+            <a:r>
+              <a:rPr lang="en-US" sz="2400" dirty="0">
+                <a:latin typeface="Times New Roman" panose="02020603050405020304" pitchFamily="18" charset="0"/>
+                <a:cs typeface="Times New Roman" panose="02020603050405020304" pitchFamily="18" charset="0"/>
+              </a:rPr>
+              <a:t>Software Design Flow</a:t>
+            </a:r>
+          </a:p>
+          <a:p>
+            <a:pPr>
+              <a:spcBef>
+                <a:spcPts val="1200"/>
+              </a:spcBef>
+            </a:pPr>
+            <a:r>
+              <a:rPr lang="en-US" sz="2400" dirty="0">
+                <a:latin typeface="Times New Roman" panose="02020603050405020304" pitchFamily="18" charset="0"/>
+                <a:cs typeface="Times New Roman" panose="02020603050405020304" pitchFamily="18" charset="0"/>
+              </a:rPr>
+              <a:t>JTAG Debug Flow</a:t>
+            </a:r>
+          </a:p>
+          <a:p>
+            <a:pPr>
+              <a:spcBef>
+                <a:spcPts val="1200"/>
+              </a:spcBef>
+            </a:pPr>
+            <a:r>
+              <a:rPr lang="en-US" sz="2400" dirty="0">
+                <a:solidFill>
+                  <a:srgbClr val="FF0000"/>
+                </a:solidFill>
+                <a:latin typeface="Times New Roman" panose="02020603050405020304" pitchFamily="18" charset="0"/>
+                <a:cs typeface="Times New Roman" panose="02020603050405020304" pitchFamily="18" charset="0"/>
+              </a:rPr>
+              <a:t>Standalone Boot Sequence</a:t>
+            </a:r>
+          </a:p>
+        </p:txBody>
+      </p:sp>
+      <p:sp>
+        <p:nvSpPr>
+          <p:cNvPr id="4" name="投影片編號版面配置區 3">
+            <a:extLst>
+              <a:ext uri="{FF2B5EF4-FFF2-40B4-BE49-F238E27FC236}">
+                <a16:creationId xmlns:a16="http://schemas.microsoft.com/office/drawing/2014/main" id="{2026C914-5B87-BB1E-25CB-FED0FD0FBFCC}"/>
+              </a:ext>
+            </a:extLst>
+          </p:cNvPr>
+          <p:cNvSpPr>
+            <a:spLocks noGrp="1"/>
+          </p:cNvSpPr>
+          <p:nvPr>
+            <p:ph type="sldNum" sz="quarter" idx="12"/>
+          </p:nvPr>
+        </p:nvSpPr>
+        <p:spPr/>
+        <p:txBody>
+          <a:bodyPr/>
+          <a:lstStyle/>
+          <a:p>
+            <a:fld id="{F9F9ED32-46C6-469E-9D81-E8934DBD0961}" type="slidenum">
+              <a:rPr lang="zh-TW" altLang="en-US" smtClean="0"/>
+              <a:t>2</a:t>
+            </a:fld>
+            <a:endParaRPr lang="zh-TW" altLang="en-US" dirty="0"/>
+          </a:p>
+        </p:txBody>
+      </p:sp>
+    </p:spTree>
+    <p:extLst>
+      <p:ext uri="{BB962C8B-B14F-4D97-AF65-F5344CB8AC3E}">
+        <p14:creationId xmlns:p14="http://schemas.microsoft.com/office/powerpoint/2010/main" val="219506187"/>
+      </p:ext>
+    </p:extLst>
+  </p:cSld>
+  <p:clrMapOvr>
+    <a:masterClrMapping/>
+  </p:clrMapOvr>
+  <mc:AlternateContent xmlns:mc="http://schemas.openxmlformats.org/markup-compatibility/2006" xmlns:p14="http://schemas.microsoft.com/office/powerpoint/2010/main">
+    <mc:Choice Requires="p14">
+      <p:transition spd="slow" p14:dur="2000">
+        <p:cut/>
+      </p:transition>
+    </mc:Choice>
+    <mc:Fallback xmlns="">
+      <p:transition spd="slow">
+        <p:cut/>
+      </p:transition>
+    </mc:Fallback>
+  </mc:AlternateContent>
+</p:sld>
+</file>
+
+<file path=ppt/slides/slide20.xml><?xml version="1.0" encoding="utf-8"?>
 <p:sld xmlns:a="http://schemas.openxmlformats.org/drawingml/2006/main" xmlns:r="http://schemas.openxmlformats.org/officeDocument/2006/relationships" xmlns:p="http://schemas.openxmlformats.org/presentationml/2006/main">
   <p:cSld>
     <p:spTree>
@@ -12246,7 +12668,7 @@
           <a:p>
             <a:fld id="{5E7A655E-BA10-45EB-B439-1EA08694B58E}" type="slidenum">
               <a:rPr lang="en-US" smtClean="0"/>
-              <a:t>19</a:t>
+              <a:t>20</a:t>
             </a:fld>
             <a:endParaRPr lang="en-US"/>
           </a:p>
@@ -14129,289 +14551,7 @@
 </p:sld>
 </file>
 
-<file path=ppt/slides/slide2.xml><?xml version="1.0" encoding="utf-8"?>
-<p:sld xmlns:a="http://schemas.openxmlformats.org/drawingml/2006/main" xmlns:r="http://schemas.openxmlformats.org/officeDocument/2006/relationships" xmlns:p="http://schemas.openxmlformats.org/presentationml/2006/main">
-  <p:cSld>
-    <p:spTree>
-      <p:nvGrpSpPr>
-        <p:cNvPr id="1" name="">
-          <a:extLst>
-            <a:ext uri="{FF2B5EF4-FFF2-40B4-BE49-F238E27FC236}">
-              <a16:creationId xmlns:a16="http://schemas.microsoft.com/office/drawing/2014/main" id="{B69280E7-411B-5B87-EFAC-03C9325D8EB4}"/>
-            </a:ext>
-          </a:extLst>
-        </p:cNvPr>
-        <p:cNvGrpSpPr/>
-        <p:nvPr/>
-      </p:nvGrpSpPr>
-      <p:grpSpPr>
-        <a:xfrm>
-          <a:off x="0" y="0"/>
-          <a:ext cx="0" cy="0"/>
-          <a:chOff x="0" y="0"/>
-          <a:chExt cx="0" cy="0"/>
-        </a:xfrm>
-      </p:grpSpPr>
-      <p:sp>
-        <p:nvSpPr>
-          <p:cNvPr id="2" name="標題 1">
-            <a:extLst>
-              <a:ext uri="{FF2B5EF4-FFF2-40B4-BE49-F238E27FC236}">
-                <a16:creationId xmlns:a16="http://schemas.microsoft.com/office/drawing/2014/main" id="{4743D012-99B4-A6AC-0CD2-999158835AC4}"/>
-              </a:ext>
-            </a:extLst>
-          </p:cNvPr>
-          <p:cNvSpPr>
-            <a:spLocks noGrp="1"/>
-          </p:cNvSpPr>
-          <p:nvPr>
-            <p:ph type="title"/>
-          </p:nvPr>
-        </p:nvSpPr>
-        <p:spPr/>
-        <p:txBody>
-          <a:bodyPr/>
-          <a:lstStyle/>
-          <a:p>
-            <a:r>
-              <a:rPr lang="en-US" altLang="zh-TW" dirty="0"/>
-              <a:t>Outline</a:t>
-            </a:r>
-            <a:endParaRPr lang="zh-TW" altLang="en-US" dirty="0"/>
-          </a:p>
-        </p:txBody>
-      </p:sp>
-      <p:sp>
-        <p:nvSpPr>
-          <p:cNvPr id="3" name="內容版面配置區 2">
-            <a:extLst>
-              <a:ext uri="{FF2B5EF4-FFF2-40B4-BE49-F238E27FC236}">
-                <a16:creationId xmlns:a16="http://schemas.microsoft.com/office/drawing/2014/main" id="{130A0642-98CF-9CEF-6C6D-052CB538B24A}"/>
-              </a:ext>
-            </a:extLst>
-          </p:cNvPr>
-          <p:cNvSpPr>
-            <a:spLocks noGrp="1"/>
-          </p:cNvSpPr>
-          <p:nvPr>
-            <p:ph idx="1"/>
-          </p:nvPr>
-        </p:nvSpPr>
-        <p:spPr/>
-        <p:txBody>
-          <a:bodyPr/>
-          <a:lstStyle/>
-          <a:p>
-            <a:pPr>
-              <a:spcBef>
-                <a:spcPts val="1200"/>
-              </a:spcBef>
-            </a:pPr>
-            <a:r>
-              <a:rPr lang="en-US" sz="2400" dirty="0">
-                <a:latin typeface="Times New Roman" panose="02020603050405020304" pitchFamily="18" charset="0"/>
-                <a:cs typeface="Times New Roman" panose="02020603050405020304" pitchFamily="18" charset="0"/>
-              </a:rPr>
-              <a:t>FPGA Selection and Spec</a:t>
-            </a:r>
-          </a:p>
-          <a:p>
-            <a:pPr>
-              <a:spcBef>
-                <a:spcPts val="1200"/>
-              </a:spcBef>
-            </a:pPr>
-            <a:r>
-              <a:rPr lang="en-US" sz="2400" dirty="0">
-                <a:latin typeface="Times New Roman" panose="02020603050405020304" pitchFamily="18" charset="0"/>
-                <a:cs typeface="Times New Roman" panose="02020603050405020304" pitchFamily="18" charset="0"/>
-              </a:rPr>
-              <a:t>Microcontroller Overview</a:t>
-            </a:r>
-          </a:p>
-          <a:p>
-            <a:pPr>
-              <a:spcBef>
-                <a:spcPts val="1200"/>
-              </a:spcBef>
-            </a:pPr>
-            <a:r>
-              <a:rPr lang="en-US" altLang="zh-TW" sz="2400" dirty="0">
-                <a:latin typeface="Times New Roman" panose="02020603050405020304" pitchFamily="18" charset="0"/>
-                <a:cs typeface="Times New Roman" panose="02020603050405020304" pitchFamily="18" charset="0"/>
-              </a:rPr>
-              <a:t>Data Path / Instruction Path</a:t>
-            </a:r>
-            <a:endParaRPr lang="en-US" sz="2400" dirty="0">
-              <a:latin typeface="Times New Roman" panose="02020603050405020304" pitchFamily="18" charset="0"/>
-              <a:cs typeface="Times New Roman" panose="02020603050405020304" pitchFamily="18" charset="0"/>
-            </a:endParaRPr>
-          </a:p>
-          <a:p>
-            <a:pPr>
-              <a:spcBef>
-                <a:spcPts val="1200"/>
-              </a:spcBef>
-            </a:pPr>
-            <a:r>
-              <a:rPr lang="en-US" sz="2400" dirty="0">
-                <a:latin typeface="Times New Roman" panose="02020603050405020304" pitchFamily="18" charset="0"/>
-                <a:cs typeface="Times New Roman" panose="02020603050405020304" pitchFamily="18" charset="0"/>
-              </a:rPr>
-              <a:t>MDM / GPIO / Interrupt System / </a:t>
-            </a:r>
-            <a:r>
-              <a:rPr lang="zh-TW" altLang="en-US" sz="2400" dirty="0">
-                <a:latin typeface="Times New Roman" panose="02020603050405020304" pitchFamily="18" charset="0"/>
-                <a:cs typeface="Times New Roman" panose="02020603050405020304" pitchFamily="18" charset="0"/>
-              </a:rPr>
-              <a:t> </a:t>
-            </a:r>
-            <a:r>
-              <a:rPr lang="en-US" altLang="zh-TW" sz="2400" dirty="0">
-                <a:latin typeface="Times New Roman" panose="02020603050405020304" pitchFamily="18" charset="0"/>
-                <a:cs typeface="Times New Roman" panose="02020603050405020304" pitchFamily="18" charset="0"/>
-              </a:rPr>
-              <a:t>Timer &amp; PWM / XADC / UART</a:t>
-            </a:r>
-          </a:p>
-          <a:p>
-            <a:pPr>
-              <a:spcBef>
-                <a:spcPts val="1200"/>
-              </a:spcBef>
-            </a:pPr>
-            <a:r>
-              <a:rPr lang="en-US" altLang="zh-TW" sz="2400" dirty="0">
-                <a:solidFill>
-                  <a:srgbClr val="FF0000"/>
-                </a:solidFill>
-                <a:latin typeface="Times New Roman" panose="02020603050405020304" pitchFamily="18" charset="0"/>
-                <a:cs typeface="Times New Roman" panose="02020603050405020304" pitchFamily="18" charset="0"/>
-              </a:rPr>
-              <a:t>Memory Hierarchy</a:t>
-            </a:r>
-          </a:p>
-          <a:p>
-            <a:pPr>
-              <a:spcBef>
-                <a:spcPts val="1200"/>
-              </a:spcBef>
-            </a:pPr>
-            <a:r>
-              <a:rPr lang="en-US" altLang="zh-TW" sz="2400" dirty="0">
-                <a:latin typeface="Times New Roman" panose="02020603050405020304" pitchFamily="18" charset="0"/>
-                <a:cs typeface="Times New Roman" panose="02020603050405020304" pitchFamily="18" charset="0"/>
-              </a:rPr>
-              <a:t>Hardware Report</a:t>
-            </a:r>
-            <a:endParaRPr lang="en-US" sz="2400" dirty="0">
-              <a:latin typeface="Times New Roman" panose="02020603050405020304" pitchFamily="18" charset="0"/>
-              <a:cs typeface="Times New Roman" panose="02020603050405020304" pitchFamily="18" charset="0"/>
-            </a:endParaRPr>
-          </a:p>
-          <a:p>
-            <a:pPr>
-              <a:spcBef>
-                <a:spcPts val="1200"/>
-              </a:spcBef>
-            </a:pPr>
-            <a:r>
-              <a:rPr lang="en-US" sz="2400" dirty="0">
-                <a:latin typeface="Times New Roman" panose="02020603050405020304" pitchFamily="18" charset="0"/>
-                <a:cs typeface="Times New Roman" panose="02020603050405020304" pitchFamily="18" charset="0"/>
-              </a:rPr>
-              <a:t>Software Design Flow</a:t>
-            </a:r>
-          </a:p>
-          <a:p>
-            <a:pPr>
-              <a:spcBef>
-                <a:spcPts val="1200"/>
-              </a:spcBef>
-            </a:pPr>
-            <a:r>
-              <a:rPr lang="en-US" sz="2400" dirty="0">
-                <a:latin typeface="Times New Roman" panose="02020603050405020304" pitchFamily="18" charset="0"/>
-                <a:cs typeface="Times New Roman" panose="02020603050405020304" pitchFamily="18" charset="0"/>
-              </a:rPr>
-              <a:t>JTAG Debug Flow</a:t>
-            </a:r>
-          </a:p>
-          <a:p>
-            <a:pPr>
-              <a:spcBef>
-                <a:spcPts val="1200"/>
-              </a:spcBef>
-            </a:pPr>
-            <a:r>
-              <a:rPr lang="en-US" sz="2400" dirty="0">
-                <a:solidFill>
-                  <a:srgbClr val="FF0000"/>
-                </a:solidFill>
-                <a:latin typeface="Times New Roman" panose="02020603050405020304" pitchFamily="18" charset="0"/>
-                <a:cs typeface="Times New Roman" panose="02020603050405020304" pitchFamily="18" charset="0"/>
-              </a:rPr>
-              <a:t>Standalone Boot Sequence</a:t>
-            </a:r>
-          </a:p>
-        </p:txBody>
-      </p:sp>
-      <p:sp>
-        <p:nvSpPr>
-          <p:cNvPr id="4" name="投影片編號版面配置區 3">
-            <a:extLst>
-              <a:ext uri="{FF2B5EF4-FFF2-40B4-BE49-F238E27FC236}">
-                <a16:creationId xmlns:a16="http://schemas.microsoft.com/office/drawing/2014/main" id="{2026C914-5B87-BB1E-25CB-FED0FD0FBFCC}"/>
-              </a:ext>
-            </a:extLst>
-          </p:cNvPr>
-          <p:cNvSpPr>
-            <a:spLocks noGrp="1"/>
-          </p:cNvSpPr>
-          <p:nvPr>
-            <p:ph type="sldNum" sz="quarter" idx="12"/>
-          </p:nvPr>
-        </p:nvSpPr>
-        <p:spPr/>
-        <p:txBody>
-          <a:bodyPr/>
-          <a:lstStyle/>
-          <a:p>
-            <a:fld id="{F9F9ED32-46C6-469E-9D81-E8934DBD0961}" type="slidenum">
-              <a:rPr lang="zh-TW" altLang="en-US" smtClean="0"/>
-              <a:t>2</a:t>
-            </a:fld>
-            <a:endParaRPr lang="zh-TW" altLang="en-US" dirty="0"/>
-          </a:p>
-        </p:txBody>
-      </p:sp>
-    </p:spTree>
-    <p:extLst>
-      <p:ext uri="{BB962C8B-B14F-4D97-AF65-F5344CB8AC3E}">
-        <p14:creationId xmlns:p14="http://schemas.microsoft.com/office/powerpoint/2010/main" val="219506187"/>
-      </p:ext>
-    </p:extLst>
-  </p:cSld>
-  <p:clrMapOvr>
-    <a:masterClrMapping/>
-  </p:clrMapOvr>
-  <mc:AlternateContent xmlns:mc="http://schemas.openxmlformats.org/markup-compatibility/2006" xmlns:p14="http://schemas.microsoft.com/office/powerpoint/2010/main">
-    <mc:Choice Requires="p14">
-      <p:transition spd="slow" p14:dur="2000">
-        <p:cut/>
-      </p:transition>
-    </mc:Choice>
-    <mc:Fallback xmlns="">
-      <p:transition spd="slow">
-        <p:cut/>
-      </p:transition>
-    </mc:Fallback>
-  </mc:AlternateContent>
-</p:sld>
-</file>
-
-<file path=ppt/slides/slide20.xml><?xml version="1.0" encoding="utf-8"?>
+<file path=ppt/slides/slide21.xml><?xml version="1.0" encoding="utf-8"?>
 <p:sld xmlns:a="http://schemas.openxmlformats.org/drawingml/2006/main" xmlns:r="http://schemas.openxmlformats.org/officeDocument/2006/relationships" xmlns:p="http://schemas.openxmlformats.org/presentationml/2006/main">
   <p:cSld>
     <p:spTree>
@@ -14663,7 +14803,7 @@
           <a:p>
             <a:fld id="{F9F9ED32-46C6-469E-9D81-E8934DBD0961}" type="slidenum">
               <a:rPr lang="zh-TW" altLang="en-US" smtClean="0"/>
-              <a:t>20</a:t>
+              <a:t>21</a:t>
             </a:fld>
             <a:endParaRPr lang="zh-TW" altLang="en-US" dirty="0"/>
           </a:p>
@@ -14694,7 +14834,7 @@
 </p:sld>
 </file>
 
-<file path=ppt/slides/slide21.xml><?xml version="1.0" encoding="utf-8"?>
+<file path=ppt/slides/slide22.xml><?xml version="1.0" encoding="utf-8"?>
 <p:sld xmlns:a="http://schemas.openxmlformats.org/drawingml/2006/main" xmlns:r="http://schemas.openxmlformats.org/officeDocument/2006/relationships" xmlns:p="http://schemas.openxmlformats.org/presentationml/2006/main">
   <p:cSld>
     <p:spTree>
@@ -14768,7 +14908,7 @@
           <a:p>
             <a:fld id="{9856DA5A-CF52-47BD-AC49-21DC5CAD2230}" type="slidenum">
               <a:rPr lang="en-TW" smtClean="0"/>
-              <a:t>21</a:t>
+              <a:t>22</a:t>
             </a:fld>
             <a:endParaRPr lang="en-TW"/>
           </a:p>
@@ -14834,7 +14974,7 @@
 </p:sld>
 </file>
 
-<file path=ppt/slides/slide22.xml><?xml version="1.0" encoding="utf-8"?>
+<file path=ppt/slides/slide23.xml><?xml version="1.0" encoding="utf-8"?>
 <p:sld xmlns:a="http://schemas.openxmlformats.org/drawingml/2006/main" xmlns:r="http://schemas.openxmlformats.org/officeDocument/2006/relationships" xmlns:p="http://schemas.openxmlformats.org/presentationml/2006/main">
   <p:cSld>
     <p:spTree>
@@ -15083,7 +15223,7 @@
           <a:p>
             <a:fld id="{F9F9ED32-46C6-469E-9D81-E8934DBD0961}" type="slidenum">
               <a:rPr lang="zh-TW" altLang="en-US" smtClean="0"/>
-              <a:t>22</a:t>
+              <a:t>23</a:t>
             </a:fld>
             <a:endParaRPr lang="zh-TW" altLang="en-US" dirty="0"/>
           </a:p>
@@ -15114,7 +15254,7 @@
 </p:sld>
 </file>
 
-<file path=ppt/slides/slide23.xml><?xml version="1.0" encoding="utf-8"?>
+<file path=ppt/slides/slide24.xml><?xml version="1.0" encoding="utf-8"?>
 <p:sld xmlns:a="http://schemas.openxmlformats.org/drawingml/2006/main" xmlns:r="http://schemas.openxmlformats.org/officeDocument/2006/relationships" xmlns:p="http://schemas.openxmlformats.org/presentationml/2006/main">
   <p:cSld>
     <p:spTree>
@@ -15354,7 +15494,7 @@
           <a:p>
             <a:fld id="{5E7A655E-BA10-45EB-B439-1EA08694B58E}" type="slidenum">
               <a:rPr lang="en-TW" smtClean="0"/>
-              <a:t>23</a:t>
+              <a:t>24</a:t>
             </a:fld>
             <a:endParaRPr lang="en-TW"/>
           </a:p>
@@ -15368,7 +15508,7 @@
 </p:sld>
 </file>
 
-<file path=ppt/slides/slide24.xml><?xml version="1.0" encoding="utf-8"?>
+<file path=ppt/slides/slide25.xml><?xml version="1.0" encoding="utf-8"?>
 <p:sld xmlns:a="http://schemas.openxmlformats.org/drawingml/2006/main" xmlns:r="http://schemas.openxmlformats.org/officeDocument/2006/relationships" xmlns:p="http://schemas.openxmlformats.org/presentationml/2006/main">
   <p:cSld>
     <p:spTree>
@@ -15620,7 +15760,7 @@
           <a:p>
             <a:fld id="{F9F9ED32-46C6-469E-9D81-E8934DBD0961}" type="slidenum">
               <a:rPr lang="zh-TW" altLang="en-US" smtClean="0"/>
-              <a:t>24</a:t>
+              <a:t>25</a:t>
             </a:fld>
             <a:endParaRPr lang="zh-TW" altLang="en-US" dirty="0"/>
           </a:p>
@@ -15651,7 +15791,7 @@
 </p:sld>
 </file>
 
-<file path=ppt/slides/slide25.xml><?xml version="1.0" encoding="utf-8"?>
+<file path=ppt/slides/slide26.xml><?xml version="1.0" encoding="utf-8"?>
 <p:sld xmlns:a="http://schemas.openxmlformats.org/drawingml/2006/main" xmlns:r="http://schemas.openxmlformats.org/officeDocument/2006/relationships" xmlns:p="http://schemas.openxmlformats.org/presentationml/2006/main">
   <p:cSld>
     <p:spTree>
@@ -15775,7 +15915,7 @@
             </a:pPr>
             <a:fld id="{00000000-1234-1234-1234-123412341234}" type="slidenum">
               <a:rPr lang="en-US" smtClean="0"/>
-              <a:t>25</a:t>
+              <a:t>26</a:t>
             </a:fld>
             <a:endParaRPr lang="en-US"/>
           </a:p>
@@ -15794,7 +15934,7 @@
 </p:sld>
 </file>
 
-<file path=ppt/slides/slide26.xml><?xml version="1.0" encoding="utf-8"?>
+<file path=ppt/slides/slide27.xml><?xml version="1.0" encoding="utf-8"?>
 <p:sld xmlns:a="http://schemas.openxmlformats.org/drawingml/2006/main" xmlns:r="http://schemas.openxmlformats.org/officeDocument/2006/relationships" xmlns:p="http://schemas.openxmlformats.org/presentationml/2006/main">
   <p:cSld>
     <p:spTree>
@@ -16029,7 +16169,7 @@
             </a:pPr>
             <a:fld id="{00000000-1234-1234-1234-123412341234}" type="slidenum">
               <a:rPr lang="en-US" smtClean="0"/>
-              <a:t>26</a:t>
+              <a:t>27</a:t>
             </a:fld>
             <a:endParaRPr lang="en-US"/>
           </a:p>
@@ -16048,7 +16188,7 @@
 </p:sld>
 </file>
 
-<file path=ppt/slides/slide27.xml><?xml version="1.0" encoding="utf-8"?>
+<file path=ppt/slides/slide28.xml><?xml version="1.0" encoding="utf-8"?>
 <p:sld xmlns:a="http://schemas.openxmlformats.org/drawingml/2006/main" xmlns:r="http://schemas.openxmlformats.org/officeDocument/2006/relationships" xmlns:p="http://schemas.openxmlformats.org/presentationml/2006/main">
   <p:cSld>
     <p:spTree>
@@ -16325,7 +16465,7 @@
             <a:fld id="{F9F9ED32-46C6-469E-9D81-E8934DBD0961}" type="slidenum">
               <a:rPr lang="zh-TW" altLang="en-US" smtClean="0"/>
               <a:pPr/>
-              <a:t>27</a:t>
+              <a:t>28</a:t>
             </a:fld>
             <a:endParaRPr lang="zh-TW" altLang="en-US" dirty="0"/>
           </a:p>
@@ -16420,7 +16560,7 @@
 </p:sld>
 </file>
 
-<file path=ppt/slides/slide28.xml><?xml version="1.0" encoding="utf-8"?>
+<file path=ppt/slides/slide29.xml><?xml version="1.0" encoding="utf-8"?>
 <p:sld xmlns:a="http://schemas.openxmlformats.org/drawingml/2006/main" xmlns:r="http://schemas.openxmlformats.org/officeDocument/2006/relationships" xmlns:p="http://schemas.openxmlformats.org/presentationml/2006/main">
   <p:cSld>
     <p:spTree>
@@ -16644,7 +16784,7 @@
             <a:fld id="{F9F9ED32-46C6-469E-9D81-E8934DBD0961}" type="slidenum">
               <a:rPr lang="zh-TW" altLang="en-US" smtClean="0"/>
               <a:pPr/>
-              <a:t>28</a:t>
+              <a:t>29</a:t>
             </a:fld>
             <a:endParaRPr lang="zh-TW" altLang="en-US" dirty="0"/>
           </a:p>
@@ -16660,289 +16800,6 @@
   <p:clrMapOvr>
     <a:masterClrMapping/>
   </p:clrMapOvr>
-</p:sld>
-</file>
-
-<file path=ppt/slides/slide29.xml><?xml version="1.0" encoding="utf-8"?>
-<p:sld xmlns:a="http://schemas.openxmlformats.org/drawingml/2006/main" xmlns:r="http://schemas.openxmlformats.org/officeDocument/2006/relationships" xmlns:p="http://schemas.openxmlformats.org/presentationml/2006/main">
-  <p:cSld>
-    <p:spTree>
-      <p:nvGrpSpPr>
-        <p:cNvPr id="1" name="">
-          <a:extLst>
-            <a:ext uri="{FF2B5EF4-FFF2-40B4-BE49-F238E27FC236}">
-              <a16:creationId xmlns:a16="http://schemas.microsoft.com/office/drawing/2014/main" id="{A5F8769B-96D5-FB86-647F-9E84199D00DD}"/>
-            </a:ext>
-          </a:extLst>
-        </p:cNvPr>
-        <p:cNvGrpSpPr/>
-        <p:nvPr/>
-      </p:nvGrpSpPr>
-      <p:grpSpPr>
-        <a:xfrm>
-          <a:off x="0" y="0"/>
-          <a:ext cx="0" cy="0"/>
-          <a:chOff x="0" y="0"/>
-          <a:chExt cx="0" cy="0"/>
-        </a:xfrm>
-      </p:grpSpPr>
-      <p:sp>
-        <p:nvSpPr>
-          <p:cNvPr id="3" name="內容版面配置區 2">
-            <a:extLst>
-              <a:ext uri="{FF2B5EF4-FFF2-40B4-BE49-F238E27FC236}">
-                <a16:creationId xmlns:a16="http://schemas.microsoft.com/office/drawing/2014/main" id="{6CAFB584-589A-4323-19D7-1DC80633D59A}"/>
-              </a:ext>
-            </a:extLst>
-          </p:cNvPr>
-          <p:cNvSpPr>
-            <a:spLocks noGrp="1"/>
-          </p:cNvSpPr>
-          <p:nvPr>
-            <p:ph idx="1"/>
-          </p:nvPr>
-        </p:nvSpPr>
-        <p:spPr/>
-        <p:txBody>
-          <a:bodyPr/>
-          <a:lstStyle/>
-          <a:p>
-            <a:pPr>
-              <a:spcBef>
-                <a:spcPts val="1200"/>
-              </a:spcBef>
-            </a:pPr>
-            <a:r>
-              <a:rPr lang="en-US" sz="2400" dirty="0">
-                <a:solidFill>
-                  <a:schemeClr val="bg2"/>
-                </a:solidFill>
-                <a:latin typeface="Times New Roman" panose="02020603050405020304" pitchFamily="18" charset="0"/>
-                <a:cs typeface="Times New Roman" panose="02020603050405020304" pitchFamily="18" charset="0"/>
-              </a:rPr>
-              <a:t>FPGA Selection and Spec</a:t>
-            </a:r>
-          </a:p>
-          <a:p>
-            <a:pPr>
-              <a:spcBef>
-                <a:spcPts val="1200"/>
-              </a:spcBef>
-            </a:pPr>
-            <a:r>
-              <a:rPr lang="en-US" sz="2400" dirty="0">
-                <a:solidFill>
-                  <a:schemeClr val="bg2"/>
-                </a:solidFill>
-                <a:latin typeface="Times New Roman" panose="02020603050405020304" pitchFamily="18" charset="0"/>
-                <a:cs typeface="Times New Roman" panose="02020603050405020304" pitchFamily="18" charset="0"/>
-              </a:rPr>
-              <a:t>Microcontroller Overview</a:t>
-            </a:r>
-          </a:p>
-          <a:p>
-            <a:pPr>
-              <a:spcBef>
-                <a:spcPts val="1200"/>
-              </a:spcBef>
-            </a:pPr>
-            <a:r>
-              <a:rPr lang="en-US" altLang="zh-TW" sz="2400" dirty="0">
-                <a:solidFill>
-                  <a:schemeClr val="bg2"/>
-                </a:solidFill>
-                <a:latin typeface="Times New Roman" panose="02020603050405020304" pitchFamily="18" charset="0"/>
-                <a:cs typeface="Times New Roman" panose="02020603050405020304" pitchFamily="18" charset="0"/>
-              </a:rPr>
-              <a:t>Data Path / Instruction Path</a:t>
-            </a:r>
-            <a:endParaRPr lang="en-US" sz="2400" dirty="0">
-              <a:solidFill>
-                <a:schemeClr val="bg2"/>
-              </a:solidFill>
-              <a:latin typeface="Times New Roman" panose="02020603050405020304" pitchFamily="18" charset="0"/>
-              <a:cs typeface="Times New Roman" panose="02020603050405020304" pitchFamily="18" charset="0"/>
-            </a:endParaRPr>
-          </a:p>
-          <a:p>
-            <a:pPr>
-              <a:spcBef>
-                <a:spcPts val="1200"/>
-              </a:spcBef>
-            </a:pPr>
-            <a:r>
-              <a:rPr lang="en-US" sz="2400" dirty="0">
-                <a:solidFill>
-                  <a:schemeClr val="bg2"/>
-                </a:solidFill>
-                <a:latin typeface="Times New Roman" panose="02020603050405020304" pitchFamily="18" charset="0"/>
-                <a:cs typeface="Times New Roman" panose="02020603050405020304" pitchFamily="18" charset="0"/>
-              </a:rPr>
-              <a:t>MDM / GPIO / Interrupt System / </a:t>
-            </a:r>
-            <a:r>
-              <a:rPr lang="zh-TW" altLang="en-US" sz="2400" dirty="0">
-                <a:solidFill>
-                  <a:schemeClr val="bg2"/>
-                </a:solidFill>
-                <a:latin typeface="Times New Roman" panose="02020603050405020304" pitchFamily="18" charset="0"/>
-                <a:cs typeface="Times New Roman" panose="02020603050405020304" pitchFamily="18" charset="0"/>
-              </a:rPr>
-              <a:t> </a:t>
-            </a:r>
-            <a:r>
-              <a:rPr lang="en-US" altLang="zh-TW" sz="2400" dirty="0">
-                <a:solidFill>
-                  <a:schemeClr val="bg2"/>
-                </a:solidFill>
-                <a:latin typeface="Times New Roman" panose="02020603050405020304" pitchFamily="18" charset="0"/>
-                <a:cs typeface="Times New Roman" panose="02020603050405020304" pitchFamily="18" charset="0"/>
-              </a:rPr>
-              <a:t>Timer &amp; PWM / XADC / UART</a:t>
-            </a:r>
-          </a:p>
-          <a:p>
-            <a:pPr>
-              <a:spcBef>
-                <a:spcPts val="1200"/>
-              </a:spcBef>
-            </a:pPr>
-            <a:r>
-              <a:rPr lang="en-US" altLang="zh-TW" sz="2400" dirty="0">
-                <a:solidFill>
-                  <a:schemeClr val="bg2"/>
-                </a:solidFill>
-                <a:latin typeface="Times New Roman" panose="02020603050405020304" pitchFamily="18" charset="0"/>
-                <a:cs typeface="Times New Roman" panose="02020603050405020304" pitchFamily="18" charset="0"/>
-              </a:rPr>
-              <a:t>Memory Hierarchy</a:t>
-            </a:r>
-          </a:p>
-          <a:p>
-            <a:pPr>
-              <a:spcBef>
-                <a:spcPts val="1200"/>
-              </a:spcBef>
-            </a:pPr>
-            <a:r>
-              <a:rPr lang="en-US" altLang="zh-TW" sz="2400" dirty="0">
-                <a:solidFill>
-                  <a:schemeClr val="bg2"/>
-                </a:solidFill>
-                <a:latin typeface="Times New Roman" panose="02020603050405020304" pitchFamily="18" charset="0"/>
-                <a:cs typeface="Times New Roman" panose="02020603050405020304" pitchFamily="18" charset="0"/>
-              </a:rPr>
-              <a:t>Hardware Report</a:t>
-            </a:r>
-            <a:endParaRPr lang="en-US" sz="2400" dirty="0">
-              <a:solidFill>
-                <a:schemeClr val="bg2"/>
-              </a:solidFill>
-              <a:latin typeface="Times New Roman" panose="02020603050405020304" pitchFamily="18" charset="0"/>
-              <a:cs typeface="Times New Roman" panose="02020603050405020304" pitchFamily="18" charset="0"/>
-            </a:endParaRPr>
-          </a:p>
-          <a:p>
-            <a:pPr>
-              <a:spcBef>
-                <a:spcPts val="1200"/>
-              </a:spcBef>
-            </a:pPr>
-            <a:r>
-              <a:rPr lang="en-US" sz="2400" dirty="0">
-                <a:solidFill>
-                  <a:schemeClr val="bg2"/>
-                </a:solidFill>
-                <a:latin typeface="Times New Roman" panose="02020603050405020304" pitchFamily="18" charset="0"/>
-                <a:cs typeface="Times New Roman" panose="02020603050405020304" pitchFamily="18" charset="0"/>
-              </a:rPr>
-              <a:t>Software Design Flow</a:t>
-            </a:r>
-          </a:p>
-          <a:p>
-            <a:pPr>
-              <a:spcBef>
-                <a:spcPts val="1200"/>
-              </a:spcBef>
-            </a:pPr>
-            <a:r>
-              <a:rPr lang="en-US" sz="2400" dirty="0">
-                <a:latin typeface="Times New Roman" panose="02020603050405020304" pitchFamily="18" charset="0"/>
-                <a:cs typeface="Times New Roman" panose="02020603050405020304" pitchFamily="18" charset="0"/>
-              </a:rPr>
-              <a:t>JTAG Debug Flow</a:t>
-            </a:r>
-          </a:p>
-          <a:p>
-            <a:pPr>
-              <a:spcBef>
-                <a:spcPts val="1200"/>
-              </a:spcBef>
-            </a:pPr>
-            <a:r>
-              <a:rPr lang="en-US" sz="2400" dirty="0">
-                <a:solidFill>
-                  <a:schemeClr val="bg2"/>
-                </a:solidFill>
-                <a:latin typeface="Times New Roman" panose="02020603050405020304" pitchFamily="18" charset="0"/>
-                <a:cs typeface="Times New Roman" panose="02020603050405020304" pitchFamily="18" charset="0"/>
-              </a:rPr>
-              <a:t>Standalone Boot Sequence</a:t>
-            </a:r>
-          </a:p>
-        </p:txBody>
-      </p:sp>
-      <p:sp>
-        <p:nvSpPr>
-          <p:cNvPr id="4" name="投影片編號版面配置區 3">
-            <a:extLst>
-              <a:ext uri="{FF2B5EF4-FFF2-40B4-BE49-F238E27FC236}">
-                <a16:creationId xmlns:a16="http://schemas.microsoft.com/office/drawing/2014/main" id="{DD7D01D4-C40B-FE2A-564A-D957653CEF40}"/>
-              </a:ext>
-            </a:extLst>
-          </p:cNvPr>
-          <p:cNvSpPr>
-            <a:spLocks noGrp="1"/>
-          </p:cNvSpPr>
-          <p:nvPr>
-            <p:ph type="sldNum" sz="quarter" idx="12"/>
-          </p:nvPr>
-        </p:nvSpPr>
-        <p:spPr/>
-        <p:txBody>
-          <a:bodyPr/>
-          <a:lstStyle/>
-          <a:p>
-            <a:fld id="{F9F9ED32-46C6-469E-9D81-E8934DBD0961}" type="slidenum">
-              <a:rPr lang="zh-TW" altLang="en-US" smtClean="0"/>
-              <a:t>29</a:t>
-            </a:fld>
-            <a:endParaRPr lang="zh-TW" altLang="en-US" dirty="0"/>
-          </a:p>
-        </p:txBody>
-      </p:sp>
-    </p:spTree>
-    <p:extLst>
-      <p:ext uri="{BB962C8B-B14F-4D97-AF65-F5344CB8AC3E}">
-        <p14:creationId xmlns:p14="http://schemas.microsoft.com/office/powerpoint/2010/main" val="1347852348"/>
-      </p:ext>
-    </p:extLst>
-  </p:cSld>
-  <p:clrMapOvr>
-    <a:masterClrMapping/>
-  </p:clrMapOvr>
-  <mc:AlternateContent xmlns:mc="http://schemas.openxmlformats.org/markup-compatibility/2006" xmlns:p14="http://schemas.microsoft.com/office/powerpoint/2010/main">
-    <mc:Choice Requires="p14">
-      <p:transition spd="slow" p14:dur="2000">
-        <p:cut/>
-      </p:transition>
-    </mc:Choice>
-    <mc:Fallback xmlns="">
-      <p:transition spd="slow">
-        <p:cut/>
-      </p:transition>
-    </mc:Fallback>
-  </mc:AlternateContent>
 </p:sld>
 </file>
 
@@ -17234,6 +17091,289 @@
   <p:cSld>
     <p:spTree>
       <p:nvGrpSpPr>
+        <p:cNvPr id="1" name="">
+          <a:extLst>
+            <a:ext uri="{FF2B5EF4-FFF2-40B4-BE49-F238E27FC236}">
+              <a16:creationId xmlns:a16="http://schemas.microsoft.com/office/drawing/2014/main" id="{A5F8769B-96D5-FB86-647F-9E84199D00DD}"/>
+            </a:ext>
+          </a:extLst>
+        </p:cNvPr>
+        <p:cNvGrpSpPr/>
+        <p:nvPr/>
+      </p:nvGrpSpPr>
+      <p:grpSpPr>
+        <a:xfrm>
+          <a:off x="0" y="0"/>
+          <a:ext cx="0" cy="0"/>
+          <a:chOff x="0" y="0"/>
+          <a:chExt cx="0" cy="0"/>
+        </a:xfrm>
+      </p:grpSpPr>
+      <p:sp>
+        <p:nvSpPr>
+          <p:cNvPr id="3" name="內容版面配置區 2">
+            <a:extLst>
+              <a:ext uri="{FF2B5EF4-FFF2-40B4-BE49-F238E27FC236}">
+                <a16:creationId xmlns:a16="http://schemas.microsoft.com/office/drawing/2014/main" id="{6CAFB584-589A-4323-19D7-1DC80633D59A}"/>
+              </a:ext>
+            </a:extLst>
+          </p:cNvPr>
+          <p:cNvSpPr>
+            <a:spLocks noGrp="1"/>
+          </p:cNvSpPr>
+          <p:nvPr>
+            <p:ph idx="1"/>
+          </p:nvPr>
+        </p:nvSpPr>
+        <p:spPr/>
+        <p:txBody>
+          <a:bodyPr/>
+          <a:lstStyle/>
+          <a:p>
+            <a:pPr>
+              <a:spcBef>
+                <a:spcPts val="1200"/>
+              </a:spcBef>
+            </a:pPr>
+            <a:r>
+              <a:rPr lang="en-US" sz="2400" dirty="0">
+                <a:solidFill>
+                  <a:schemeClr val="bg2"/>
+                </a:solidFill>
+                <a:latin typeface="Times New Roman" panose="02020603050405020304" pitchFamily="18" charset="0"/>
+                <a:cs typeface="Times New Roman" panose="02020603050405020304" pitchFamily="18" charset="0"/>
+              </a:rPr>
+              <a:t>FPGA Selection and Spec</a:t>
+            </a:r>
+          </a:p>
+          <a:p>
+            <a:pPr>
+              <a:spcBef>
+                <a:spcPts val="1200"/>
+              </a:spcBef>
+            </a:pPr>
+            <a:r>
+              <a:rPr lang="en-US" sz="2400" dirty="0">
+                <a:solidFill>
+                  <a:schemeClr val="bg2"/>
+                </a:solidFill>
+                <a:latin typeface="Times New Roman" panose="02020603050405020304" pitchFamily="18" charset="0"/>
+                <a:cs typeface="Times New Roman" panose="02020603050405020304" pitchFamily="18" charset="0"/>
+              </a:rPr>
+              <a:t>Microcontroller Overview</a:t>
+            </a:r>
+          </a:p>
+          <a:p>
+            <a:pPr>
+              <a:spcBef>
+                <a:spcPts val="1200"/>
+              </a:spcBef>
+            </a:pPr>
+            <a:r>
+              <a:rPr lang="en-US" altLang="zh-TW" sz="2400" dirty="0">
+                <a:solidFill>
+                  <a:schemeClr val="bg2"/>
+                </a:solidFill>
+                <a:latin typeface="Times New Roman" panose="02020603050405020304" pitchFamily="18" charset="0"/>
+                <a:cs typeface="Times New Roman" panose="02020603050405020304" pitchFamily="18" charset="0"/>
+              </a:rPr>
+              <a:t>Data Path / Instruction Path</a:t>
+            </a:r>
+            <a:endParaRPr lang="en-US" sz="2400" dirty="0">
+              <a:solidFill>
+                <a:schemeClr val="bg2"/>
+              </a:solidFill>
+              <a:latin typeface="Times New Roman" panose="02020603050405020304" pitchFamily="18" charset="0"/>
+              <a:cs typeface="Times New Roman" panose="02020603050405020304" pitchFamily="18" charset="0"/>
+            </a:endParaRPr>
+          </a:p>
+          <a:p>
+            <a:pPr>
+              <a:spcBef>
+                <a:spcPts val="1200"/>
+              </a:spcBef>
+            </a:pPr>
+            <a:r>
+              <a:rPr lang="en-US" sz="2400" dirty="0">
+                <a:solidFill>
+                  <a:schemeClr val="bg2"/>
+                </a:solidFill>
+                <a:latin typeface="Times New Roman" panose="02020603050405020304" pitchFamily="18" charset="0"/>
+                <a:cs typeface="Times New Roman" panose="02020603050405020304" pitchFamily="18" charset="0"/>
+              </a:rPr>
+              <a:t>MDM / GPIO / Interrupt System / </a:t>
+            </a:r>
+            <a:r>
+              <a:rPr lang="zh-TW" altLang="en-US" sz="2400" dirty="0">
+                <a:solidFill>
+                  <a:schemeClr val="bg2"/>
+                </a:solidFill>
+                <a:latin typeface="Times New Roman" panose="02020603050405020304" pitchFamily="18" charset="0"/>
+                <a:cs typeface="Times New Roman" panose="02020603050405020304" pitchFamily="18" charset="0"/>
+              </a:rPr>
+              <a:t> </a:t>
+            </a:r>
+            <a:r>
+              <a:rPr lang="en-US" altLang="zh-TW" sz="2400" dirty="0">
+                <a:solidFill>
+                  <a:schemeClr val="bg2"/>
+                </a:solidFill>
+                <a:latin typeface="Times New Roman" panose="02020603050405020304" pitchFamily="18" charset="0"/>
+                <a:cs typeface="Times New Roman" panose="02020603050405020304" pitchFamily="18" charset="0"/>
+              </a:rPr>
+              <a:t>Timer &amp; PWM / XADC / UART</a:t>
+            </a:r>
+          </a:p>
+          <a:p>
+            <a:pPr>
+              <a:spcBef>
+                <a:spcPts val="1200"/>
+              </a:spcBef>
+            </a:pPr>
+            <a:r>
+              <a:rPr lang="en-US" altLang="zh-TW" sz="2400" dirty="0">
+                <a:solidFill>
+                  <a:schemeClr val="bg2"/>
+                </a:solidFill>
+                <a:latin typeface="Times New Roman" panose="02020603050405020304" pitchFamily="18" charset="0"/>
+                <a:cs typeface="Times New Roman" panose="02020603050405020304" pitchFamily="18" charset="0"/>
+              </a:rPr>
+              <a:t>Memory Hierarchy</a:t>
+            </a:r>
+          </a:p>
+          <a:p>
+            <a:pPr>
+              <a:spcBef>
+                <a:spcPts val="1200"/>
+              </a:spcBef>
+            </a:pPr>
+            <a:r>
+              <a:rPr lang="en-US" altLang="zh-TW" sz="2400" dirty="0">
+                <a:solidFill>
+                  <a:schemeClr val="bg2"/>
+                </a:solidFill>
+                <a:latin typeface="Times New Roman" panose="02020603050405020304" pitchFamily="18" charset="0"/>
+                <a:cs typeface="Times New Roman" panose="02020603050405020304" pitchFamily="18" charset="0"/>
+              </a:rPr>
+              <a:t>Hardware Report</a:t>
+            </a:r>
+            <a:endParaRPr lang="en-US" sz="2400" dirty="0">
+              <a:solidFill>
+                <a:schemeClr val="bg2"/>
+              </a:solidFill>
+              <a:latin typeface="Times New Roman" panose="02020603050405020304" pitchFamily="18" charset="0"/>
+              <a:cs typeface="Times New Roman" panose="02020603050405020304" pitchFamily="18" charset="0"/>
+            </a:endParaRPr>
+          </a:p>
+          <a:p>
+            <a:pPr>
+              <a:spcBef>
+                <a:spcPts val="1200"/>
+              </a:spcBef>
+            </a:pPr>
+            <a:r>
+              <a:rPr lang="en-US" sz="2400" dirty="0">
+                <a:solidFill>
+                  <a:schemeClr val="bg2"/>
+                </a:solidFill>
+                <a:latin typeface="Times New Roman" panose="02020603050405020304" pitchFamily="18" charset="0"/>
+                <a:cs typeface="Times New Roman" panose="02020603050405020304" pitchFamily="18" charset="0"/>
+              </a:rPr>
+              <a:t>Software Design Flow</a:t>
+            </a:r>
+          </a:p>
+          <a:p>
+            <a:pPr>
+              <a:spcBef>
+                <a:spcPts val="1200"/>
+              </a:spcBef>
+            </a:pPr>
+            <a:r>
+              <a:rPr lang="en-US" sz="2400" dirty="0">
+                <a:latin typeface="Times New Roman" panose="02020603050405020304" pitchFamily="18" charset="0"/>
+                <a:cs typeface="Times New Roman" panose="02020603050405020304" pitchFamily="18" charset="0"/>
+              </a:rPr>
+              <a:t>JTAG Debug Flow</a:t>
+            </a:r>
+          </a:p>
+          <a:p>
+            <a:pPr>
+              <a:spcBef>
+                <a:spcPts val="1200"/>
+              </a:spcBef>
+            </a:pPr>
+            <a:r>
+              <a:rPr lang="en-US" sz="2400" dirty="0">
+                <a:solidFill>
+                  <a:schemeClr val="bg2"/>
+                </a:solidFill>
+                <a:latin typeface="Times New Roman" panose="02020603050405020304" pitchFamily="18" charset="0"/>
+                <a:cs typeface="Times New Roman" panose="02020603050405020304" pitchFamily="18" charset="0"/>
+              </a:rPr>
+              <a:t>Standalone Boot Sequence</a:t>
+            </a:r>
+          </a:p>
+        </p:txBody>
+      </p:sp>
+      <p:sp>
+        <p:nvSpPr>
+          <p:cNvPr id="4" name="投影片編號版面配置區 3">
+            <a:extLst>
+              <a:ext uri="{FF2B5EF4-FFF2-40B4-BE49-F238E27FC236}">
+                <a16:creationId xmlns:a16="http://schemas.microsoft.com/office/drawing/2014/main" id="{DD7D01D4-C40B-FE2A-564A-D957653CEF40}"/>
+              </a:ext>
+            </a:extLst>
+          </p:cNvPr>
+          <p:cNvSpPr>
+            <a:spLocks noGrp="1"/>
+          </p:cNvSpPr>
+          <p:nvPr>
+            <p:ph type="sldNum" sz="quarter" idx="12"/>
+          </p:nvPr>
+        </p:nvSpPr>
+        <p:spPr/>
+        <p:txBody>
+          <a:bodyPr/>
+          <a:lstStyle/>
+          <a:p>
+            <a:fld id="{F9F9ED32-46C6-469E-9D81-E8934DBD0961}" type="slidenum">
+              <a:rPr lang="zh-TW" altLang="en-US" smtClean="0"/>
+              <a:t>30</a:t>
+            </a:fld>
+            <a:endParaRPr lang="zh-TW" altLang="en-US" dirty="0"/>
+          </a:p>
+        </p:txBody>
+      </p:sp>
+    </p:spTree>
+    <p:extLst>
+      <p:ext uri="{BB962C8B-B14F-4D97-AF65-F5344CB8AC3E}">
+        <p14:creationId xmlns:p14="http://schemas.microsoft.com/office/powerpoint/2010/main" val="1347852348"/>
+      </p:ext>
+    </p:extLst>
+  </p:cSld>
+  <p:clrMapOvr>
+    <a:masterClrMapping/>
+  </p:clrMapOvr>
+  <mc:AlternateContent xmlns:mc="http://schemas.openxmlformats.org/markup-compatibility/2006" xmlns:p14="http://schemas.microsoft.com/office/powerpoint/2010/main">
+    <mc:Choice Requires="p14">
+      <p:transition spd="slow" p14:dur="2000">
+        <p:cut/>
+      </p:transition>
+    </mc:Choice>
+    <mc:Fallback xmlns="">
+      <p:transition spd="slow">
+        <p:cut/>
+      </p:transition>
+    </mc:Fallback>
+  </mc:AlternateContent>
+</p:sld>
+</file>
+
+<file path=ppt/slides/slide31.xml><?xml version="1.0" encoding="utf-8"?>
+<p:sld xmlns:a="http://schemas.openxmlformats.org/drawingml/2006/main" xmlns:r="http://schemas.openxmlformats.org/officeDocument/2006/relationships" xmlns:p="http://schemas.openxmlformats.org/presentationml/2006/main">
+  <p:cSld>
+    <p:spTree>
+      <p:nvGrpSpPr>
         <p:cNvPr id="1" name=""/>
         <p:cNvGrpSpPr/>
         <p:nvPr/>
@@ -17298,7 +17438,7 @@
             <a:fld id="{F9F9ED32-46C6-469E-9D81-E8934DBD0961}" type="slidenum">
               <a:rPr lang="zh-TW" altLang="en-US" smtClean="0"/>
               <a:pPr/>
-              <a:t>30</a:t>
+              <a:t>31</a:t>
             </a:fld>
             <a:endParaRPr lang="zh-TW" altLang="en-US" dirty="0"/>
           </a:p>
@@ -17359,7 +17499,7 @@
 </p:sld>
 </file>
 
-<file path=ppt/slides/slide31.xml><?xml version="1.0" encoding="utf-8"?>
+<file path=ppt/slides/slide32.xml><?xml version="1.0" encoding="utf-8"?>
 <p:sld xmlns:a="http://schemas.openxmlformats.org/drawingml/2006/main" xmlns:r="http://schemas.openxmlformats.org/officeDocument/2006/relationships" xmlns:p="http://schemas.openxmlformats.org/presentationml/2006/main">
   <p:cSld>
     <p:spTree>
@@ -17611,7 +17751,7 @@
           <a:p>
             <a:fld id="{F9F9ED32-46C6-469E-9D81-E8934DBD0961}" type="slidenum">
               <a:rPr lang="zh-TW" altLang="en-US" smtClean="0"/>
-              <a:t>31</a:t>
+              <a:t>32</a:t>
             </a:fld>
             <a:endParaRPr lang="zh-TW" altLang="en-US" dirty="0"/>
           </a:p>
@@ -17642,7 +17782,7 @@
 </p:sld>
 </file>
 
-<file path=ppt/slides/slide32.xml><?xml version="1.0" encoding="utf-8"?>
+<file path=ppt/slides/slide33.xml><?xml version="1.0" encoding="utf-8"?>
 <p:sld xmlns:a="http://schemas.openxmlformats.org/drawingml/2006/main" xmlns:r="http://schemas.openxmlformats.org/officeDocument/2006/relationships" xmlns:p="http://schemas.openxmlformats.org/presentationml/2006/main">
   <p:cSld>
     <p:spTree>
@@ -17836,7 +17976,7 @@
           <a:p>
             <a:fld id="{5E7A655E-BA10-45EB-B439-1EA08694B58E}" type="slidenum">
               <a:rPr lang="en-TW" smtClean="0"/>
-              <a:t>32</a:t>
+              <a:t>33</a:t>
             </a:fld>
             <a:endParaRPr lang="en-TW"/>
           </a:p>
@@ -17850,7 +17990,7 @@
 </p:sld>
 </file>
 
-<file path=ppt/slides/slide33.xml><?xml version="1.0" encoding="utf-8"?>
+<file path=ppt/slides/slide34.xml><?xml version="1.0" encoding="utf-8"?>
 <p:sld xmlns:a="http://schemas.openxmlformats.org/drawingml/2006/main" xmlns:r="http://schemas.openxmlformats.org/officeDocument/2006/relationships" xmlns:p="http://schemas.openxmlformats.org/presentationml/2006/main">
   <p:cSld>
     <p:spTree>
@@ -18021,7 +18161,7 @@
             <a:fld id="{F9F9ED32-46C6-469E-9D81-E8934DBD0961}" type="slidenum">
               <a:rPr lang="zh-TW" altLang="en-US" smtClean="0"/>
               <a:pPr/>
-              <a:t>33</a:t>
+              <a:t>34</a:t>
             </a:fld>
             <a:endParaRPr lang="zh-TW" altLang="en-US" dirty="0"/>
           </a:p>
@@ -18040,7 +18180,7 @@
 </p:sld>
 </file>
 
-<file path=ppt/slides/slide34.xml><?xml version="1.0" encoding="utf-8"?>
+<file path=ppt/slides/slide35.xml><?xml version="1.0" encoding="utf-8"?>
 <p:sld xmlns:a="http://schemas.openxmlformats.org/drawingml/2006/main" xmlns:r="http://schemas.openxmlformats.org/officeDocument/2006/relationships" xmlns:p="http://schemas.openxmlformats.org/presentationml/2006/main">
   <p:cSld>
     <p:spTree>
@@ -18286,7 +18426,7 @@
           <a:p>
             <a:fld id="{F9F9ED32-46C6-469E-9D81-E8934DBD0961}" type="slidenum">
               <a:rPr lang="zh-TW" altLang="en-US" smtClean="0"/>
-              <a:t>34</a:t>
+              <a:t>35</a:t>
             </a:fld>
             <a:endParaRPr lang="zh-TW" altLang="en-US" dirty="0"/>
           </a:p>

</xml_diff>